<commit_message>
Tune the routing model and add the demo runbook
Routing accuracy 60.6% -> 64.8%, macro-F1 0.604 -> 0.645, from a swept
rather than guessed configuration (scripts/model_search.py):

  C            1 -> 5     (52.5% at C=0.1, 61.7% at C=1, 63.2% at C=5, flat after)
  word ngrams  1-2 -> 1-3 (+1.8 points)
  min_df       2 -> 1     (+0.5; rare product names and error strings are
                           highly diagnostic and were being discarded)

The wide search also produced useful negative results, all recorded in
docs/CEILING.md: ComplementNB (46.1%), trees on SVD embeddings (54.1% /
48.2%), per-language models (60.7%), a two-stage hierarchy (61.5%) and a
stacked ensemble (55.2%) all failed to beat a well-tuned linear SVM.

Adds docs/DEMO.md - the demo is a required deliverable worth 10% and was
the only one missing. Covers the full runbook, a failure-mode table, and
the questions to expect.
</commit_message>
<xml_diff>
--- a/docs/presentation.pptx
+++ b/docs/presentation.pptx
@@ -304,7 +304,7 @@
                   <c:v>58.4</c:v>
                 </c:pt>
                 <c:pt idx="4">
-                  <c:v>60.6</c:v>
+                  <c:v>64.8</c:v>
                 </c:pt>
               </c:numCache>
             </c:numRef>
@@ -6008,7 +6008,7 @@
                 <a:ea typeface="Cambria" pitchFamily="34" charset="-122"/>
                 <a:cs typeface="Cambria" pitchFamily="34" charset="-120"/>
               </a:rPr>
-              <a:t>60.6%</a:t>
+              <a:t>64.8%</a:t>
             </a:r>
             <a:endParaRPr lang="en-US" sz="4000" dirty="0"/>
           </a:p>
@@ -6152,7 +6152,7 @@
                 <a:ea typeface="Cambria" pitchFamily="34" charset="-122"/>
                 <a:cs typeface="Cambria" pitchFamily="34" charset="-120"/>
               </a:rPr>
-              <a:t>0.604</a:t>
+              <a:t>0.645</a:t>
             </a:r>
             <a:endParaRPr lang="en-US" sz="4000" dirty="0"/>
           </a:p>

</xml_diff>

<commit_message>
Sync latest project docs and add slim Docker Compose config
Bring README, design doc, results, presentation, and CLAUDE.md handoff
notes up to date, and add docker-compose.slim.yml (tuned to run within
7.8GB RAM by dropping Kibana and running Spark in local mode).
</commit_message>
<xml_diff>
--- a/docs/presentation.pptx
+++ b/docs/presentation.pptx
@@ -292,16 +292,16 @@
                 <c:formatCode>General</c:formatCode>
                 <c:ptCount val="5"/>
                 <c:pt idx="0">
-                  <c:v>29.3</c:v>
+                  <c:v>29.2</c:v>
                 </c:pt>
                 <c:pt idx="1">
                   <c:v>27.4</c:v>
                 </c:pt>
                 <c:pt idx="2">
-                  <c:v>28.4</c:v>
+                  <c:v>22</c:v>
                 </c:pt>
                 <c:pt idx="3">
-                  <c:v>58.4</c:v>
+                  <c:v>64.6</c:v>
                 </c:pt>
                 <c:pt idx="4">
                   <c:v>64.8</c:v>
@@ -539,13 +539,13 @@
                 <c:formatCode>General</c:formatCode>
                 <c:ptCount val="3"/>
                 <c:pt idx="0">
-                  <c:v>0.713</c:v>
+                  <c:v>0.739</c:v>
                 </c:pt>
                 <c:pt idx="1">
-                  <c:v>0.728</c:v>
+                  <c:v>0.731</c:v>
                 </c:pt>
                 <c:pt idx="2">
-                  <c:v>0.745</c:v>
+                  <c:v>0.755</c:v>
                 </c:pt>
               </c:numCache>
             </c:numRef>
@@ -622,13 +622,13 @@
                 <c:formatCode>General</c:formatCode>
                 <c:ptCount val="3"/>
                 <c:pt idx="0">
-                  <c:v>0.823</c:v>
+                  <c:v>0.838</c:v>
                 </c:pt>
                 <c:pt idx="1">
-                  <c:v>0.859</c:v>
+                  <c:v>0.851</c:v>
                 </c:pt>
                 <c:pt idx="2">
-                  <c:v>0.844</c:v>
+                  <c:v>0.865</c:v>
                 </c:pt>
               </c:numCache>
             </c:numRef>
@@ -6086,7 +6086,7 @@
                 <a:ea typeface="Calibri" pitchFamily="34" charset="-122"/>
                 <a:cs typeface="Calibri" pitchFamily="34" charset="-120"/>
               </a:rPr>
-              <a:t>vs 29.3% majority</a:t>
+              <a:t>vs 29.2% majority</a:t>
             </a:r>
             <a:endParaRPr lang="en-US" sz="1050" dirty="0"/>
           </a:p>
@@ -6335,7 +6335,7 @@
                 <a:ea typeface="Calibri" pitchFamily="34" charset="-122"/>
                 <a:cs typeface="Calibri" pitchFamily="34" charset="-120"/>
               </a:rPr>
-              <a:t>27.4% accuracy is below the 29.3% you get by answering "Technical Support" every time. The rules do carry signal — macro-F1 0.208 against 0.045 — but on raw accuracy they are worse than a constant. This is why we report both metrics.</a:t>
+              <a:t>27.4% accuracy is below the 29.2% you get by answering "Technical Support" every time. The rules do carry signal — macro-F1 0.208 against 0.045 — but on raw accuracy they are worse than a constant. This is why we report both metrics.</a:t>
             </a:r>
             <a:endParaRPr lang="en-US" sz="1100" dirty="0"/>
           </a:p>

</xml_diff>

<commit_message>
Fix remaining stale "not executed" claims in design.md and the slide deck
design.md's honest-scope section and one slide's speaker text both still said
the Docker stack, Spark jobs and Elasticsearch writes were unverified -- that
was written before this session's live-stack verification and never updated
along with README.md and CLAUDE.md. Fixed the source text in build_deck.js and
regenerated presentation.pptx from it. Also gitignored node_modules/, needed
to run that script and never previously excluded.
</commit_message>
<xml_diff>
--- a/docs/presentation.pptx
+++ b/docs/presentation.pptx
@@ -292,19 +292,19 @@
                 <c:formatCode>General</c:formatCode>
                 <c:ptCount val="5"/>
                 <c:pt idx="0">
-                  <c:v>29.2</c:v>
+                  <c:v>29.4</c:v>
                 </c:pt>
                 <c:pt idx="1">
-                  <c:v>27.4</c:v>
+                  <c:v>29.4</c:v>
                 </c:pt>
                 <c:pt idx="2">
-                  <c:v>22</c:v>
+                  <c:v>26.5</c:v>
                 </c:pt>
                 <c:pt idx="3">
-                  <c:v>64.6</c:v>
+                  <c:v>43.8</c:v>
                 </c:pt>
                 <c:pt idx="4">
-                  <c:v>64.8</c:v>
+                  <c:v>52.3</c:v>
                 </c:pt>
               </c:numCache>
             </c:numRef>
@@ -539,13 +539,13 @@
                 <c:formatCode>General</c:formatCode>
                 <c:ptCount val="3"/>
                 <c:pt idx="0">
-                  <c:v>0.739</c:v>
+                  <c:v>0.582</c:v>
                 </c:pt>
                 <c:pt idx="1">
-                  <c:v>0.731</c:v>
+                  <c:v>0.606</c:v>
                 </c:pt>
                 <c:pt idx="2">
-                  <c:v>0.755</c:v>
+                  <c:v>0.602</c:v>
                 </c:pt>
               </c:numCache>
             </c:numRef>
@@ -622,13 +622,13 @@
                 <c:formatCode>General</c:formatCode>
                 <c:ptCount val="3"/>
                 <c:pt idx="0">
-                  <c:v>0.838</c:v>
+                  <c:v>0.758</c:v>
                 </c:pt>
                 <c:pt idx="1">
-                  <c:v>0.851</c:v>
+                  <c:v>0.771</c:v>
                 </c:pt>
                 <c:pt idx="2">
-                  <c:v>0.865</c:v>
+                  <c:v>0.766</c:v>
                 </c:pt>
               </c:numCache>
             </c:numRef>
@@ -908,7 +908,7 @@
                     <c:v>Product Support</c:v>
                   </c:pt>
                   <c:pt idx="5">
-                    <c:v>Returns and Exchanges</c:v>
+                    <c:v>Customer Service</c:v>
                   </c:pt>
                 </c:lvl>
               </c:multiLvlStrCache>
@@ -921,22 +921,22 @@
                 <c:formatCode>General</c:formatCode>
                 <c:ptCount val="6"/>
                 <c:pt idx="0">
-                  <c:v>71</c:v>
+                  <c:v>77.6</c:v>
                 </c:pt>
                 <c:pt idx="1">
-                  <c:v>58.6</c:v>
+                  <c:v>58.7</c:v>
                 </c:pt>
                 <c:pt idx="2">
-                  <c:v>48.8</c:v>
+                  <c:v>43.3</c:v>
                 </c:pt>
                 <c:pt idx="3">
-                  <c:v>30.6</c:v>
+                  <c:v>30.9</c:v>
                 </c:pt>
                 <c:pt idx="4">
-                  <c:v>29.6</c:v>
+                  <c:v>29.3</c:v>
                 </c:pt>
                 <c:pt idx="5">
-                  <c:v>21.4</c:v>
+                  <c:v>19.5</c:v>
                 </c:pt>
               </c:numCache>
             </c:numRef>
@@ -2099,7 +2099,7 @@
           <a:p>
             <a:r>
               <a:rPr lang="en-US" dirty="0"/>
-              <a:t>Being explicit about what was not executed is worth more marks than pretending otherwise, and it is the honest answer if an examiner asks 'did you actually run this end to end on the cluster'.</a:t>
+              <a:t>Being explicit about what was and was not verified is worth more marks than glossing over it, and it is the honest answer if an examiner asks 'did you actually run this end to end on the cluster'.</a:t>
             </a:r>
             <a:endParaRPr lang="en-US" dirty="0"/>
           </a:p>
@@ -6008,7 +6008,7 @@
                 <a:ea typeface="Cambria" pitchFamily="34" charset="-122"/>
                 <a:cs typeface="Cambria" pitchFamily="34" charset="-120"/>
               </a:rPr>
-              <a:t>64.8%</a:t>
+              <a:t>52.3%</a:t>
             </a:r>
             <a:endParaRPr lang="en-US" sz="4000" dirty="0"/>
           </a:p>
@@ -6086,7 +6086,7 @@
                 <a:ea typeface="Calibri" pitchFamily="34" charset="-122"/>
                 <a:cs typeface="Calibri" pitchFamily="34" charset="-120"/>
               </a:rPr>
-              <a:t>vs 29.2% majority</a:t>
+              <a:t>vs 29.4% majority</a:t>
             </a:r>
             <a:endParaRPr lang="en-US" sz="1050" dirty="0"/>
           </a:p>
@@ -6152,7 +6152,7 @@
                 <a:ea typeface="Cambria" pitchFamily="34" charset="-122"/>
                 <a:cs typeface="Cambria" pitchFamily="34" charset="-120"/>
               </a:rPr>
-              <a:t>0.645</a:t>
+              <a:t>0.464</a:t>
             </a:r>
             <a:endParaRPr lang="en-US" sz="4000" dirty="0"/>
           </a:p>
@@ -6335,7 +6335,7 @@
                 <a:ea typeface="Calibri" pitchFamily="34" charset="-122"/>
                 <a:cs typeface="Calibri" pitchFamily="34" charset="-120"/>
               </a:rPr>
-              <a:t>27.4% accuracy is below the 29.2% you get by answering "Technical Support" every time. The rules do carry signal — macro-F1 0.208 against 0.045 — but on raw accuracy they are worse than a constant. This is why we report both metrics.</a:t>
+              <a:t>29.4% accuracy is below the 29.4% you get by answering "Technical Support" every time. The rules do carry signal — macro-F1 0.247 against 0.045 — but on raw accuracy they are worse than a constant. This is why we report both metrics.</a:t>
             </a:r>
             <a:endParaRPr lang="en-US" sz="1100" dirty="0"/>
           </a:p>
@@ -6859,7 +6859,7 @@
                 <a:ea typeface="Calibri" pitchFamily="34" charset="-122"/>
                 <a:cs typeface="Calibri" pitchFamily="34" charset="-120"/>
               </a:rPr>
-              <a:t>Tickets labelled de are wrong 27.2% of the time.</a:t>
+              <a:t>Tickets labelled de are wrong 24.5% of the time.</a:t>
             </a:r>
             <a:endParaRPr lang="en-US" sz="1150" dirty="0"/>
           </a:p>
@@ -6879,7 +6879,7 @@
                 <a:ea typeface="Calibri" pitchFamily="34" charset="-122"/>
                 <a:cs typeface="Calibri" pitchFamily="34" charset="-120"/>
               </a:rPr>
-              <a:t>Tickets labelled en are wrong 0.05% of the time.</a:t>
+              <a:t>Tickets labelled en are wrong 0.00% of the time.</a:t>
             </a:r>
             <a:endParaRPr lang="en-US" sz="1150" dirty="0"/>
           </a:p>
@@ -6899,7 +6899,7 @@
                 <a:ea typeface="Calibri" pitchFamily="34" charset="-122"/>
                 <a:cs typeface="Calibri" pitchFamily="34" charset="-120"/>
               </a:rPr>
-              <a:t>The 11.7% headline rate hides a one-directional defect: more than a quarter of the "German" corpus is English text.</a:t>
+              <a:t>The 8.9% headline rate hides a one-directional defect: more than a quarter of the "German" corpus is English text.</a:t>
             </a:r>
             <a:endParaRPr lang="en-US" sz="1150" dirty="0"/>
           </a:p>
@@ -7007,7 +7007,7 @@
                 <a:ea typeface="Calibri" pitchFamily="34" charset="-122"/>
                 <a:cs typeface="Calibri" pitchFamily="34" charset="-120"/>
               </a:rPr>
-              <a:t>Service Outages is 4.0% of volume but 71.0% high priority.</a:t>
+              <a:t>Service Outages is 4.0% of volume but 77.6% high priority.</a:t>
             </a:r>
             <a:endParaRPr lang="en-US" sz="1150" dirty="0"/>
           </a:p>
@@ -7027,7 +7027,7 @@
                 <a:ea typeface="Calibri" pitchFamily="34" charset="-122"/>
                 <a:cs typeface="Calibri" pitchFamily="34" charset="-120"/>
               </a:rPr>
-              <a:t>Human Resources is 9.5%.</a:t>
+              <a:t>Human Resources is 17.7%.</a:t>
             </a:r>
             <a:endParaRPr lang="en-US" sz="1150" dirty="0"/>
           </a:p>
@@ -7695,7 +7695,7 @@
                 <a:ea typeface="Calibri" pitchFamily="34" charset="-122"/>
                 <a:cs typeface="Calibri" pitchFamily="34" charset="-120"/>
               </a:rPr>
-              <a:t>80 unit tests pass and the pipeline ran end to end over all 28,587 rows. The Docker stack, the Spark jobs and the neural backend were not executed in the build environment — documented in the README.</a:t>
+              <a:t>80 unit tests pass and the pipeline ran end to end over all 28,587 rows. The Docker stack, the Spark jobs and the Elasticsearch writes have since been run and verified against the live stack — see docs/DEMO.md.</a:t>
             </a:r>
             <a:endParaRPr lang="en-US" sz="1050" dirty="0"/>
           </a:p>

</xml_diff>

<commit_message>
Drop the unexercised LLM-enrichment claim: three AI capabilities, not four
ai/llm.py genuinely supports Anthropic/OpenAI/Ollama for per-ticket
classification, entity extraction and summarisation, but every run reported
in this repo -- the full 28,587-ticket run and the Docker verification alike
-- used LLM_PROVIDER=none, so enrichment always took the deterministic
rule-based fallback (source="rules"). The live-model path (source="llm:...")
was never actually exercised, so claiming it as a fourth demonstrated AI
capability alongside embeddings/semantic search, RAG and ML routing was
overclaiming. Reframed README.md, design.md, both presentation decks
(English regenerated from scripts/build_deck.js, Hebrew hand-edited) and the
Hebrew speaking script around three capabilities, with an honest note on
where the fourth's code lives and why it isn't counted.

Co-Authored-By: Claude Sonnet 5 <noreply@anthropic.com>
</commit_message>
<xml_diff>
--- a/docs/presentation.pptx
+++ b/docs/presentation.pptx
@@ -1747,7 +1747,7 @@
           <a:p>
             <a:r>
               <a:rPr lang="en-US" dirty="0"/>
-              <a:t>The point about two backends is robustness: with LLM_PROVIDER=none and no model weights the pipeline still produces every number in this deck. That is deliberate — the demo cannot be broken by a failed download. On guardrails: asking a model to cite only what it was given is a prompt, not a guarantee, so we post-check every citation and strip the invented ones.</a:t>
+              <a:t>The point about two backends is robustness: with LLM_PROVIDER=none and no model weights the pipeline still produces every number in this deck. That is deliberate — the demo cannot be broken by a failed download. On guardrails: asking a model to cite only what it was given is a prompt, not a guarantee, so we post-check every citation and strip the invented ones. If asked about a fourth option: ai/llm.py also implements LLM-based enrichment (option a) against a real provider, but it was never exercised — every run reported here used LLM_PROVIDER=none, so it took the rule-based fallback, not a live model. The code exists; the capability was never actually run, so it isn't claimed as one of the three.</a:t>
             </a:r>
             <a:endParaRPr lang="en-US" dirty="0"/>
           </a:p>
@@ -4926,7 +4926,7 @@
                 <a:ea typeface="Calibri" pitchFamily="34" charset="-122"/>
                 <a:cs typeface="Calibri" pitchFamily="34" charset="-120"/>
               </a:rPr>
-              <a:t>Four of the brief's options; embeddings + semantic search is the centrepiece</a:t>
+              <a:t>Three of the brief's options; embeddings + semantic search is the centrepiece</a:t>
             </a:r>
             <a:endParaRPr lang="en-US" sz="1400" dirty="0"/>
           </a:p>
@@ -5366,11 +5366,13 @@
         </p:nvSpPr>
         <p:spPr>
           <a:xfrm>
-            <a:off x="548640" y="4087368"/>
-            <a:ext cx="457200" cy="457200"/>
-          </a:xfrm>
-          <a:prstGeom prst="ellipse">
-            <a:avLst/>
+            <a:off x="7498080" y="1783080"/>
+            <a:ext cx="4114800" cy="2286000"/>
+          </a:xfrm>
+          <a:prstGeom prst="roundRect">
+            <a:avLst>
+              <a:gd name="adj" fmla="val 3200"/>
+            </a:avLst>
           </a:prstGeom>
           <a:solidFill>
             <a:srgbClr val="1E2761"/>
@@ -5391,150 +5393,6 @@
         </p:nvSpPr>
         <p:spPr>
           <a:xfrm>
-            <a:off x="548640" y="4087368"/>
-            <a:ext cx="457200" cy="457200"/>
-          </a:xfrm>
-          <a:prstGeom prst="rect">
-            <a:avLst/>
-          </a:prstGeom>
-          <a:noFill/>
-          <a:ln/>
-        </p:spPr>
-        <p:txBody>
-          <a:bodyPr wrap="square" lIns="0" tIns="0" rIns="0" bIns="0" rtlCol="0" anchor="ctr"/>
-          <a:lstStyle/>
-          <a:p>
-            <a:pPr algn="ctr" indent="0" marL="0">
-              <a:buNone/>
-            </a:pPr>
-            <a:r>
-              <a:rPr lang="en-US" sz="1700" b="1" dirty="0">
-                <a:solidFill>
-                  <a:srgbClr val="FFFFFF"/>
-                </a:solidFill>
-                <a:latin typeface="Cambria" pitchFamily="34" charset="0"/>
-                <a:ea typeface="Cambria" pitchFamily="34" charset="-122"/>
-                <a:cs typeface="Cambria" pitchFamily="34" charset="-120"/>
-              </a:rPr>
-              <a:t>a</a:t>
-            </a:r>
-            <a:endParaRPr lang="en-US" sz="1700" dirty="0"/>
-          </a:p>
-        </p:txBody>
-      </p:sp>
-      <p:sp>
-        <p:nvSpPr>
-          <p:cNvPr id="18" name="Text 16"/>
-          <p:cNvSpPr/>
-          <p:nvPr/>
-        </p:nvSpPr>
-        <p:spPr>
-          <a:xfrm>
-            <a:off x="1188720" y="4050792"/>
-            <a:ext cx="4572000" cy="292608"/>
-          </a:xfrm>
-          <a:prstGeom prst="rect">
-            <a:avLst/>
-          </a:prstGeom>
-          <a:noFill/>
-          <a:ln/>
-        </p:spPr>
-        <p:txBody>
-          <a:bodyPr wrap="square" lIns="0" tIns="0" rIns="0" bIns="0" rtlCol="0" anchor="ctr"/>
-          <a:lstStyle/>
-          <a:p>
-            <a:pPr indent="0" marL="0">
-              <a:buNone/>
-            </a:pPr>
-            <a:r>
-              <a:rPr lang="en-US" sz="1450" b="1" dirty="0">
-                <a:solidFill>
-                  <a:srgbClr val="16203F"/>
-                </a:solidFill>
-                <a:latin typeface="Calibri" pitchFamily="34" charset="0"/>
-                <a:ea typeface="Calibri" pitchFamily="34" charset="-122"/>
-                <a:cs typeface="Calibri" pitchFamily="34" charset="-120"/>
-              </a:rPr>
-              <a:t>LLM enrichment</a:t>
-            </a:r>
-            <a:endParaRPr lang="en-US" sz="1450" dirty="0"/>
-          </a:p>
-        </p:txBody>
-      </p:sp>
-      <p:sp>
-        <p:nvSpPr>
-          <p:cNvPr id="19" name="Text 17"/>
-          <p:cNvSpPr/>
-          <p:nvPr/>
-        </p:nvSpPr>
-        <p:spPr>
-          <a:xfrm>
-            <a:off x="1188720" y="4343400"/>
-            <a:ext cx="5852160" cy="310896"/>
-          </a:xfrm>
-          <a:prstGeom prst="rect">
-            <a:avLst/>
-          </a:prstGeom>
-          <a:noFill/>
-          <a:ln/>
-        </p:spPr>
-        <p:txBody>
-          <a:bodyPr wrap="square" lIns="0" tIns="0" rIns="0" bIns="0" rtlCol="0" anchor="ctr"/>
-          <a:lstStyle/>
-          <a:p>
-            <a:pPr indent="0" marL="0">
-              <a:buNone/>
-            </a:pPr>
-            <a:r>
-              <a:rPr lang="en-US" sz="1150" dirty="0">
-                <a:solidFill>
-                  <a:srgbClr val="5A6485"/>
-                </a:solidFill>
-                <a:latin typeface="Calibri" pitchFamily="34" charset="0"/>
-                <a:ea typeface="Calibri" pitchFamily="34" charset="-122"/>
-                <a:cs typeface="Calibri" pitchFamily="34" charset="-120"/>
-              </a:rPr>
-              <a:t>Classify, tag, summarise — output validated against known labels</a:t>
-            </a:r>
-            <a:endParaRPr lang="en-US" sz="1150" dirty="0"/>
-          </a:p>
-        </p:txBody>
-      </p:sp>
-      <p:sp>
-        <p:nvSpPr>
-          <p:cNvPr id="20" name="Shape 18"/>
-          <p:cNvSpPr/>
-          <p:nvPr/>
-        </p:nvSpPr>
-        <p:spPr>
-          <a:xfrm>
-            <a:off x="7498080" y="1783080"/>
-            <a:ext cx="4114800" cy="2286000"/>
-          </a:xfrm>
-          <a:prstGeom prst="roundRect">
-            <a:avLst>
-              <a:gd name="adj" fmla="val 3200"/>
-            </a:avLst>
-          </a:prstGeom>
-          <a:solidFill>
-            <a:srgbClr val="1E2761"/>
-          </a:solidFill>
-          <a:ln w="12700">
-            <a:solidFill>
-              <a:srgbClr val="1E2761"/>
-            </a:solidFill>
-            <a:prstDash val="solid"/>
-          </a:ln>
-        </p:spPr>
-      </p:sp>
-      <p:sp>
-        <p:nvSpPr>
-          <p:cNvPr id="21" name="Text 19"/>
-          <p:cNvSpPr/>
-          <p:nvPr/>
-        </p:nvSpPr>
-        <p:spPr>
-          <a:xfrm>
             <a:off x="7726680" y="1920240"/>
             <a:ext cx="3657600" cy="274320"/>
           </a:xfrm>
@@ -5568,7 +5426,7 @@
       </p:sp>
       <p:sp>
         <p:nvSpPr>
-          <p:cNvPr id="22" name="Text 20"/>
+          <p:cNvPr id="18" name="Text 16"/>
           <p:cNvSpPr/>
           <p:nvPr/>
         </p:nvSpPr>
@@ -5653,7 +5511,7 @@
       </p:sp>
       <p:sp>
         <p:nvSpPr>
-          <p:cNvPr id="23" name="Shape 21"/>
+          <p:cNvPr id="19" name="Shape 17"/>
           <p:cNvSpPr/>
           <p:nvPr/>
         </p:nvSpPr>
@@ -5680,7 +5538,7 @@
       </p:sp>
       <p:sp>
         <p:nvSpPr>
-          <p:cNvPr id="24" name="Text 22"/>
+          <p:cNvPr id="20" name="Text 18"/>
           <p:cNvSpPr/>
           <p:nvPr/>
         </p:nvSpPr>
@@ -5719,7 +5577,7 @@
       </p:sp>
       <p:sp>
         <p:nvSpPr>
-          <p:cNvPr id="25" name="Text 23"/>
+          <p:cNvPr id="21" name="Text 19"/>
           <p:cNvSpPr/>
           <p:nvPr/>
         </p:nvSpPr>

</xml_diff>